<commit_message>
Use viridis figures and remove duplicate tables
</commit_message>
<xml_diff>
--- a/manuscripts/eplacement_kyc_v4_1_validation/editable_figures_1_4.pptx
+++ b/manuscripts/eplacement_kyc_v4_1_validation/editable_figures_1_4.pptx
@@ -3221,11 +3221,11 @@
             <a:avLst/>
           </a:prstGeom>
           <a:solidFill>
-            <a:srgbClr val="2550D8"/>
+            <a:srgbClr val="31688E"/>
           </a:solidFill>
           <a:ln>
             <a:solidFill>
-              <a:srgbClr val="2550D8"/>
+              <a:srgbClr val="31688E"/>
             </a:solidFill>
           </a:ln>
         </p:spPr>
@@ -3416,11 +3416,11 @@
             <a:avLst/>
           </a:prstGeom>
           <a:solidFill>
-            <a:srgbClr val="D97706"/>
+            <a:srgbClr val="5DC863"/>
           </a:solidFill>
           <a:ln>
             <a:solidFill>
-              <a:srgbClr val="D97706"/>
+              <a:srgbClr val="5DC863"/>
             </a:solidFill>
           </a:ln>
         </p:spPr>
@@ -3611,11 +3611,11 @@
             <a:avLst/>
           </a:prstGeom>
           <a:solidFill>
-            <a:srgbClr val="0F766E"/>
+            <a:srgbClr val="21918C"/>
           </a:solidFill>
           <a:ln>
             <a:solidFill>
-              <a:srgbClr val="0F766E"/>
+              <a:srgbClr val="21918C"/>
             </a:solidFill>
           </a:ln>
         </p:spPr>
@@ -3806,11 +3806,11 @@
             <a:avLst/>
           </a:prstGeom>
           <a:solidFill>
-            <a:srgbClr val="15803D"/>
+            <a:srgbClr val="35B779"/>
           </a:solidFill>
           <a:ln>
             <a:solidFill>
-              <a:srgbClr val="15803D"/>
+              <a:srgbClr val="35B779"/>
             </a:solidFill>
           </a:ln>
         </p:spPr>
@@ -3977,7 +3977,7 @@
             <a:r>
               <a:rPr sz="1800" b="1">
                 <a:solidFill>
-                  <a:srgbClr val="0F766E"/>
+                  <a:srgbClr val="21918C"/>
                 </a:solidFill>
                 <a:latin typeface="Aptos"/>
               </a:rPr>
@@ -4092,7 +4092,7 @@
             <a:r>
               <a:rPr sz="1800" b="1">
                 <a:solidFill>
-                  <a:srgbClr val="0F766E"/>
+                  <a:srgbClr val="21918C"/>
                 </a:solidFill>
                 <a:latin typeface="Aptos"/>
               </a:rPr>
@@ -4207,7 +4207,7 @@
             <a:r>
               <a:rPr sz="1800" b="1">
                 <a:solidFill>
-                  <a:srgbClr val="0F766E"/>
+                  <a:srgbClr val="21918C"/>
                 </a:solidFill>
                 <a:latin typeface="Aptos"/>
               </a:rPr>
@@ -4322,7 +4322,7 @@
             <a:r>
               <a:rPr sz="1800" b="1">
                 <a:solidFill>
-                  <a:srgbClr val="0F766E"/>
+                  <a:srgbClr val="21918C"/>
                 </a:solidFill>
                 <a:latin typeface="Aptos"/>
               </a:rPr>
@@ -4549,11 +4549,11 @@
             <a:avLst/>
           </a:prstGeom>
           <a:solidFill>
-            <a:srgbClr val="2550D8"/>
+            <a:srgbClr val="31688E"/>
           </a:solidFill>
           <a:ln>
             <a:solidFill>
-              <a:srgbClr val="2550D8"/>
+              <a:srgbClr val="31688E"/>
             </a:solidFill>
           </a:ln>
         </p:spPr>
@@ -4709,11 +4709,11 @@
             <a:avLst/>
           </a:prstGeom>
           <a:solidFill>
-            <a:srgbClr val="0F766E"/>
+            <a:srgbClr val="21918C"/>
           </a:solidFill>
           <a:ln>
             <a:solidFill>
-              <a:srgbClr val="0F766E"/>
+              <a:srgbClr val="21918C"/>
             </a:solidFill>
           </a:ln>
         </p:spPr>
@@ -4869,11 +4869,11 @@
             <a:avLst/>
           </a:prstGeom>
           <a:solidFill>
-            <a:srgbClr val="D97706"/>
+            <a:srgbClr val="5DC863"/>
           </a:solidFill>
           <a:ln>
             <a:solidFill>
-              <a:srgbClr val="D97706"/>
+              <a:srgbClr val="5DC863"/>
             </a:solidFill>
           </a:ln>
         </p:spPr>
@@ -5029,11 +5029,11 @@
             <a:avLst/>
           </a:prstGeom>
           <a:solidFill>
-            <a:srgbClr val="7C3AED"/>
+            <a:srgbClr val="440154"/>
           </a:solidFill>
           <a:ln>
             <a:solidFill>
-              <a:srgbClr val="7C3AED"/>
+              <a:srgbClr val="440154"/>
             </a:solidFill>
           </a:ln>
         </p:spPr>
@@ -5189,11 +5189,11 @@
             <a:avLst/>
           </a:prstGeom>
           <a:solidFill>
-            <a:srgbClr val="15803D"/>
+            <a:srgbClr val="35B779"/>
           </a:solidFill>
           <a:ln>
             <a:solidFill>
-              <a:srgbClr val="15803D"/>
+              <a:srgbClr val="35B779"/>
             </a:solidFill>
           </a:ln>
         </p:spPr>
@@ -5349,11 +5349,11 @@
             <a:avLst/>
           </a:prstGeom>
           <a:solidFill>
-            <a:srgbClr val="B91C1C"/>
+            <a:srgbClr val="FDE725"/>
           </a:solidFill>
           <a:ln>
             <a:solidFill>
-              <a:srgbClr val="B91C1C"/>
+              <a:srgbClr val="FDE725"/>
             </a:solidFill>
           </a:ln>
         </p:spPr>
@@ -5651,11 +5651,11 @@
             <a:avLst/>
           </a:prstGeom>
           <a:solidFill>
-            <a:srgbClr val="2550D8"/>
+            <a:srgbClr val="31688E"/>
           </a:solidFill>
           <a:ln>
             <a:solidFill>
-              <a:srgbClr val="2550D8"/>
+              <a:srgbClr val="31688E"/>
             </a:solidFill>
           </a:ln>
         </p:spPr>
@@ -5846,11 +5846,11 @@
             <a:avLst/>
           </a:prstGeom>
           <a:solidFill>
-            <a:srgbClr val="0F766E"/>
+            <a:srgbClr val="21918C"/>
           </a:solidFill>
           <a:ln>
             <a:solidFill>
-              <a:srgbClr val="0F766E"/>
+              <a:srgbClr val="21918C"/>
             </a:solidFill>
           </a:ln>
         </p:spPr>
@@ -6041,11 +6041,11 @@
             <a:avLst/>
           </a:prstGeom>
           <a:solidFill>
-            <a:srgbClr val="D97706"/>
+            <a:srgbClr val="5DC863"/>
           </a:solidFill>
           <a:ln>
             <a:solidFill>
-              <a:srgbClr val="D97706"/>
+              <a:srgbClr val="5DC863"/>
             </a:solidFill>
           </a:ln>
         </p:spPr>
@@ -6236,11 +6236,11 @@
             <a:avLst/>
           </a:prstGeom>
           <a:solidFill>
-            <a:srgbClr val="2550D8"/>
+            <a:srgbClr val="31688E"/>
           </a:solidFill>
           <a:ln>
             <a:solidFill>
-              <a:srgbClr val="2550D8"/>
+              <a:srgbClr val="31688E"/>
             </a:solidFill>
           </a:ln>
         </p:spPr>
@@ -6431,11 +6431,11 @@
             <a:avLst/>
           </a:prstGeom>
           <a:solidFill>
-            <a:srgbClr val="0F766E"/>
+            <a:srgbClr val="21918C"/>
           </a:solidFill>
           <a:ln>
             <a:solidFill>
-              <a:srgbClr val="0F766E"/>
+              <a:srgbClr val="21918C"/>
             </a:solidFill>
           </a:ln>
         </p:spPr>
@@ -6626,11 +6626,11 @@
             <a:avLst/>
           </a:prstGeom>
           <a:solidFill>
-            <a:srgbClr val="D97706"/>
+            <a:srgbClr val="5DC863"/>
           </a:solidFill>
           <a:ln>
             <a:solidFill>
-              <a:srgbClr val="D97706"/>
+              <a:srgbClr val="5DC863"/>
             </a:solidFill>
           </a:ln>
         </p:spPr>
@@ -6821,11 +6821,11 @@
             <a:avLst/>
           </a:prstGeom>
           <a:solidFill>
-            <a:srgbClr val="2550D8"/>
+            <a:srgbClr val="31688E"/>
           </a:solidFill>
           <a:ln>
             <a:solidFill>
-              <a:srgbClr val="2550D8"/>
+              <a:srgbClr val="31688E"/>
             </a:solidFill>
           </a:ln>
         </p:spPr>
@@ -7482,11 +7482,11 @@
             <a:avLst/>
           </a:prstGeom>
           <a:solidFill>
-            <a:srgbClr val="2550D8"/>
+            <a:srgbClr val="31688E"/>
           </a:solidFill>
           <a:ln>
             <a:solidFill>
-              <a:srgbClr val="2550D8"/>
+              <a:srgbClr val="31688E"/>
             </a:solidFill>
           </a:ln>
         </p:spPr>
@@ -7677,11 +7677,11 @@
             <a:avLst/>
           </a:prstGeom>
           <a:solidFill>
-            <a:srgbClr val="0F766E"/>
+            <a:srgbClr val="21918C"/>
           </a:solidFill>
           <a:ln>
             <a:solidFill>
-              <a:srgbClr val="0F766E"/>
+              <a:srgbClr val="21918C"/>
             </a:solidFill>
           </a:ln>
         </p:spPr>
@@ -7872,11 +7872,11 @@
             <a:avLst/>
           </a:prstGeom>
           <a:solidFill>
-            <a:srgbClr val="D97706"/>
+            <a:srgbClr val="5DC863"/>
           </a:solidFill>
           <a:ln>
             <a:solidFill>
-              <a:srgbClr val="D97706"/>
+              <a:srgbClr val="5DC863"/>
             </a:solidFill>
           </a:ln>
         </p:spPr>
@@ -8067,11 +8067,11 @@
             <a:avLst/>
           </a:prstGeom>
           <a:solidFill>
-            <a:srgbClr val="7C3AED"/>
+            <a:srgbClr val="440154"/>
           </a:solidFill>
           <a:ln>
             <a:solidFill>
-              <a:srgbClr val="7C3AED"/>
+              <a:srgbClr val="440154"/>
             </a:solidFill>
           </a:ln>
         </p:spPr>
@@ -8262,11 +8262,11 @@
             <a:avLst/>
           </a:prstGeom>
           <a:solidFill>
-            <a:srgbClr val="15803D"/>
+            <a:srgbClr val="35B779"/>
           </a:solidFill>
           <a:ln>
             <a:solidFill>
-              <a:srgbClr val="15803D"/>
+              <a:srgbClr val="35B779"/>
             </a:solidFill>
           </a:ln>
         </p:spPr>
@@ -8433,7 +8433,7 @@
             <a:r>
               <a:rPr sz="1700" b="1">
                 <a:solidFill>
-                  <a:srgbClr val="0F766E"/>
+                  <a:srgbClr val="21918C"/>
                 </a:solidFill>
                 <a:latin typeface="Aptos"/>
               </a:rPr>

</xml_diff>